<commit_message>
docs: add the combined Review 2 / Final Demonstration submission and refresh the demo deck
Replaces the August report with a 50-page submission that maps every official
deliverable to evidence, follows the 22-section template, and includes live
screenshots, rendered architecture and ER diagrams, the deployment log and the
demonstration script. Deck updated to the deployed state and 161 tests.
</commit_message>
<xml_diff>
--- a/docs/ServiceDesk_AI_Final_Demo.pptx
+++ b/docs/ServiceDesk_AI_Final_Demo.pptx
@@ -2107,7 +2107,7 @@
                 <a:ea typeface="Calibri" pitchFamily="34" charset="-122"/>
                 <a:cs typeface="Calibri" pitchFamily="34" charset="-120"/>
               </a:rPr>
-              <a:t>Project 19  ·  Customer Support SaaS  ·  Final Demonstration  ·  15 October 2026</a:t>
+              <a:t>Project 19  ·  Customer Support SaaS  ·  Review 2 &amp; Final Demonstration  ·  September 2026</a:t>
             </a:r>
             <a:endParaRPr lang="en-US" sz="1200" dirty="0"/>
           </a:p>
@@ -2427,7 +2427,7 @@
                 <a:ea typeface="Calibri" pitchFamily="34" charset="-122"/>
                 <a:cs typeface="Calibri" pitchFamily="34" charset="-120"/>
               </a:rPr>
-              <a:t>REMAINING WORK</a:t>
+              <a:t>AS DEPLOYED</a:t>
             </a:r>
             <a:endParaRPr lang="en-US" sz="1100" dirty="0"/>
           </a:p>
@@ -2508,7 +2508,7 @@
                 <a:ea typeface="Calibri" pitchFamily="34" charset="-122"/>
                 <a:cs typeface="Calibri" pitchFamily="34" charset="-120"/>
               </a:rPr>
-              <a:t>Three tiers, deployed in dependency order. Each step is documented with its exact settings, environment variables and verification checks.</a:t>
+              <a:t>Three tiers plus messaging, deployed from a version-controlled Blueprint. Every step below was performed and verified; the problems met are in the report.</a:t>
             </a:r>
             <a:endParaRPr lang="en-US" sz="1250" dirty="0"/>
           </a:p>
@@ -2679,7 +2679,7 @@
                 <a:ea typeface="Calibri" pitchFamily="34" charset="-122"/>
                 <a:cs typeface="Calibri" pitchFamily="34" charset="-120"/>
               </a:rPr>
-              <a:t>Supabase</a:t>
+              <a:t>Render PostgreSQL 16</a:t>
             </a:r>
             <a:endParaRPr lang="en-US" sz="1050" dirty="0"/>
           </a:p>
@@ -2721,7 +2721,7 @@
                 <a:ea typeface="Calibri" pitchFamily="34" charset="-122"/>
                 <a:cs typeface="Calibri" pitchFamily="34" charset="-120"/>
               </a:rPr>
-              <a:t>Create the project, copy the pooled connection string, run migrate and seed</a:t>
+              <a:t>Provisioned by render.yaml in Singapore with pgvector; migrations run on every start; seeded once</a:t>
             </a:r>
             <a:endParaRPr lang="en-US" sz="1050" dirty="0"/>
           </a:p>
@@ -2760,7 +2760,7 @@
                 <a:ea typeface="Calibri" pitchFamily="34" charset="-122"/>
                 <a:cs typeface="Calibri" pitchFamily="34" charset="-120"/>
               </a:rPr>
-              <a:t>20 min</a:t>
+              <a:t>done</a:t>
             </a:r>
             <a:endParaRPr lang="en-US" sz="1050" dirty="0"/>
           </a:p>
@@ -2973,7 +2973,7 @@
                 <a:ea typeface="Calibri" pitchFamily="34" charset="-122"/>
                 <a:cs typeface="Calibri" pitchFamily="34" charset="-120"/>
               </a:rPr>
-              <a:t>Root = backend, build and start commands, health check path, environment variables</a:t>
+              <a:t>Web service from the same Blueprint: npm ci --include=dev, migrate &amp;&amp; start, /api/health, generated JWT secrets</a:t>
             </a:r>
             <a:endParaRPr lang="en-US" sz="1050" dirty="0"/>
           </a:p>
@@ -3012,7 +3012,7 @@
                 <a:ea typeface="Calibri" pitchFamily="34" charset="-122"/>
                 <a:cs typeface="Calibri" pitchFamily="34" charset="-120"/>
               </a:rPr>
-              <a:t>20 min</a:t>
+              <a:t>done</a:t>
             </a:r>
             <a:endParaRPr lang="en-US" sz="1050" dirty="0"/>
           </a:p>
@@ -3225,7 +3225,7 @@
                 <a:ea typeface="Calibri" pitchFamily="34" charset="-122"/>
                 <a:cs typeface="Calibri" pitchFamily="34" charset="-120"/>
               </a:rPr>
-              <a:t>Root = frontend, Vite preset, set the API base URL, SPA rewrite for deep links</a:t>
+              <a:t>servicedesk-ai-two.vercel.app — root frontend, Vite preset, one public variable: the API base URL</a:t>
             </a:r>
             <a:endParaRPr lang="en-US" sz="1050" dirty="0"/>
           </a:p>
@@ -3264,7 +3264,7 @@
                 <a:ea typeface="Calibri" pitchFamily="34" charset="-122"/>
                 <a:cs typeface="Calibri" pitchFamily="34" charset="-120"/>
               </a:rPr>
-              <a:t>15 min</a:t>
+              <a:t>done</a:t>
             </a:r>
             <a:endParaRPr lang="en-US" sz="1050" dirty="0"/>
           </a:p>
@@ -3396,7 +3396,7 @@
                 <a:ea typeface="Cambria" pitchFamily="34" charset="-122"/>
                 <a:cs typeface="Cambria" pitchFamily="34" charset="-120"/>
               </a:rPr>
-              <a:t>CORS</a:t>
+              <a:t>WhatsApp</a:t>
             </a:r>
             <a:endParaRPr lang="en-US" sz="1450" dirty="0"/>
           </a:p>
@@ -3477,7 +3477,7 @@
                 <a:ea typeface="Calibri" pitchFamily="34" charset="-122"/>
                 <a:cs typeface="Calibri" pitchFamily="34" charset="-120"/>
               </a:rPr>
-              <a:t>Set the origin to the exact Vercel URL and redeploy — no wildcard, credentials are sent</a:t>
+              <a:t>Meta WhatsApp Cloud API: signed webhook to /api/whatsapp/webhook, app subscribed to the business account</a:t>
             </a:r>
             <a:endParaRPr lang="en-US" sz="1050" dirty="0"/>
           </a:p>
@@ -3516,7 +3516,7 @@
                 <a:ea typeface="Calibri" pitchFamily="34" charset="-122"/>
                 <a:cs typeface="Calibri" pitchFamily="34" charset="-120"/>
               </a:rPr>
-              <a:t>5 min</a:t>
+              <a:t>done</a:t>
             </a:r>
             <a:endParaRPr lang="en-US" sz="1050" dirty="0"/>
           </a:p>
@@ -3631,7 +3631,7 @@
                 <a:ea typeface="Calibri" pitchFamily="34" charset="-122"/>
                 <a:cs typeface="Calibri" pitchFamily="34" charset="-120"/>
               </a:rPr>
-              <a:t>The API instance sleeps after 15 minutes idle, so the first request takes ~50 s. A scheduled ping to the health endpoint every 10 minutes keeps both the API and the database awake.</a:t>
+              <a:t>The free API instance sleeps after 15 minutes idle. An UptimeRobot ping to /api/health every 5 minutes keeps it awake for the demonstration.</a:t>
             </a:r>
             <a:endParaRPr lang="en-US" sz="1100" dirty="0"/>
           </a:p>
@@ -3746,7 +3746,7 @@
                 <a:ea typeface="Calibri" pitchFamily="34" charset="-122"/>
                 <a:cs typeface="Calibri" pitchFamily="34" charset="-120"/>
               </a:rPr>
-              <a:t>After deploying, grep the built JavaScript for the AI key. It must return nothing — that is the proof it never reaches the browser.</a:t>
+              <a:t>The Vercel project holds exactly one variable, the API base URL. No AI key, WhatsApp token or database credential ever reaches the browser.</a:t>
             </a:r>
             <a:endParaRPr lang="en-US" sz="1100" dirty="0"/>
           </a:p>
@@ -3822,7 +3822,7 @@
                 <a:ea typeface="Calibri" pitchFamily="34" charset="-122"/>
                 <a:cs typeface="Calibri" pitchFamily="34" charset="-120"/>
               </a:rPr>
-              <a:t>An 11-point verification checklist follows deployment: health, registration, cookie behaviour, ticket creation, AI draft, dashboards, deep-link refresh, mobile layout, and the credential check.</a:t>
+              <a:t>Verified live: health, registration, cookie behaviour, ticket creation, AI draft, dashboards, Swagger, mobile layout, and a WhatsApp round trip from a phone in about one second.</a:t>
             </a:r>
             <a:endParaRPr lang="en-US" sz="1200" dirty="0"/>
           </a:p>
@@ -3861,7 +3861,7 @@
                 <a:ea typeface="Calibri" pitchFamily="34" charset="-122"/>
                 <a:cs typeface="Calibri" pitchFamily="34" charset="-120"/>
               </a:rPr>
-              <a:t>ServiceDesk AI  ·  BCSE408L Cloud Computing  ·  Final Demonstration</a:t>
+              <a:t>ServiceDesk AI  ·  BCSE408L Cloud Computing  ·  Review 2 &amp; Final Demonstration</a:t>
             </a:r>
             <a:endParaRPr lang="en-US" sz="900" dirty="0"/>
           </a:p>
@@ -4086,7 +4086,7 @@
                 <a:ea typeface="Cambria" pitchFamily="34" charset="-122"/>
                 <a:cs typeface="Cambria" pitchFamily="34" charset="-120"/>
               </a:rPr>
-              <a:t>Email notifications</a:t>
+              <a:t>Production WhatsApp number</a:t>
             </a:r>
             <a:endParaRPr lang="en-US" sz="1500" dirty="0"/>
           </a:p>
@@ -4128,7 +4128,7 @@
                 <a:ea typeface="Calibri" pitchFamily="34" charset="-122"/>
                 <a:cs typeface="Calibri" pitchFamily="34" charset="-120"/>
               </a:rPr>
-              <a:t>Reaches customers who do not sign in — removes the main reason they telephone to ask for progress</a:t>
+              <a:t>Meta business verification lifts the five-recipient limit of the test number and enables templates outside the 24-hour window</a:t>
             </a:r>
             <a:endParaRPr lang="en-US" sz="1150" dirty="0"/>
           </a:p>
@@ -4638,7 +4638,7 @@
                 <a:ea typeface="Cambria" pitchFamily="34" charset="-122"/>
                 <a:cs typeface="Cambria" pitchFamily="34" charset="-120"/>
               </a:rPr>
-              <a:t>Knowledge base</a:t>
+              <a:t>Semantic embeddings</a:t>
             </a:r>
             <a:endParaRPr lang="en-US" sz="1500" dirty="0"/>
           </a:p>
@@ -4680,7 +4680,7 @@
                 <a:ea typeface="Calibri" pitchFamily="34" charset="-122"/>
                 <a:cs typeface="Calibri" pitchFamily="34" charset="-120"/>
               </a:rPr>
-              <a:t>Suggested articles as the customer types would deflect repeat questions before they become tickets</a:t>
+              <a:t>The knowledge base ships with a lexical fallback embedding; semantic embeddings by default would lift retrieval hit@3 above today’s 61.5%</a:t>
             </a:r>
             <a:endParaRPr lang="en-US" sz="1150" dirty="0"/>
           </a:p>
@@ -5192,7 +5192,7 @@
                 <a:ea typeface="Calibri" pitchFamily="34" charset="-122"/>
                 <a:cs typeface="Calibri" pitchFamily="34" charset="-120"/>
               </a:rPr>
-              <a:t>ServiceDesk AI  ·  BCSE408L Cloud Computing  ·  Final Demonstration</a:t>
+              <a:t>ServiceDesk AI  ·  BCSE408L Cloud Computing  ·  Review 2 &amp; Final Demonstration</a:t>
             </a:r>
             <a:endParaRPr lang="en-US" sz="900" dirty="0"/>
           </a:p>
@@ -5775,7 +5775,7 @@
                 <a:ea typeface="Calibri" pitchFamily="34" charset="-122"/>
                 <a:cs typeface="Calibri" pitchFamily="34" charset="-120"/>
               </a:rPr>
-              <a:t>92 passed · 0 failed · against real PostgreSQL</a:t>
+              <a:t>161 passed · 0 failed · against real PostgreSQL · CI green</a:t>
             </a:r>
             <a:endParaRPr lang="en-US" sz="1250" dirty="0"/>
           </a:p>
@@ -5853,7 +5853,7 @@
                 <a:ea typeface="Calibri" pitchFamily="34" charset="-122"/>
                 <a:cs typeface="Calibri" pitchFamily="34" charset="-120"/>
               </a:rPr>
-              <a:t>Not yet deployed — deployment is documented and pending</a:t>
+              <a:t>servicedesk-ai-two.vercel.app  ·  API servicedesk-api-ss2d.onrender.com/api</a:t>
             </a:r>
             <a:endParaRPr lang="en-US" sz="1250" dirty="0"/>
           </a:p>
@@ -6044,7 +6044,7 @@
                 <a:ea typeface="Calibri" pitchFamily="34" charset="-122"/>
                 <a:cs typeface="Calibri" pitchFamily="34" charset="-120"/>
               </a:rPr>
-              <a:t>A complete customer support platform: three roles, a guarded ticket lifecycle, dashboards and reports on live data, and an AI assistance layer that never acts without a human.</a:t>
+              <a:t>A deployed customer support platform: WhatsApp as the intake channel, three roles, a guarded ticket lifecycle, dashboards and reports on live data, and an AI layer that never acts without a human.</a:t>
             </a:r>
             <a:endParaRPr lang="en-US" sz="1300" dirty="0"/>
           </a:p>
@@ -6117,7 +6117,7 @@
                 <a:ea typeface="Cambria" pitchFamily="34" charset="-122"/>
                 <a:cs typeface="Cambria" pitchFamily="34" charset="-120"/>
               </a:rPr>
-              <a:t>40</a:t>
+              <a:t>64</a:t>
             </a:r>
             <a:endParaRPr lang="en-US" sz="3400" dirty="0"/>
           </a:p>
@@ -6198,7 +6198,7 @@
                 <a:ea typeface="Calibri" pitchFamily="34" charset="-122"/>
                 <a:cs typeface="Calibri" pitchFamily="34" charset="-120"/>
               </a:rPr>
-              <a:t>across 9 groups</a:t>
+              <a:t>across 11 groups</a:t>
             </a:r>
             <a:endParaRPr lang="en-US" sz="1100" dirty="0"/>
           </a:p>
@@ -6271,7 +6271,7 @@
                 <a:ea typeface="Cambria" pitchFamily="34" charset="-122"/>
                 <a:cs typeface="Cambria" pitchFamily="34" charset="-120"/>
               </a:rPr>
-              <a:t>17</a:t>
+              <a:t>19</a:t>
             </a:r>
             <a:endParaRPr lang="en-US" sz="3400" dirty="0"/>
           </a:p>
@@ -6425,7 +6425,7 @@
                 <a:ea typeface="Cambria" pitchFamily="34" charset="-122"/>
                 <a:cs typeface="Cambria" pitchFamily="34" charset="-120"/>
               </a:rPr>
-              <a:t>8</a:t>
+              <a:t>12</a:t>
             </a:r>
             <a:endParaRPr lang="en-US" sz="3400" dirty="0"/>
           </a:p>
@@ -6579,7 +6579,7 @@
                 <a:ea typeface="Cambria" pitchFamily="34" charset="-122"/>
                 <a:cs typeface="Cambria" pitchFamily="34" charset="-120"/>
               </a:rPr>
-              <a:t>92</a:t>
+              <a:t>161</a:t>
             </a:r>
             <a:endParaRPr lang="en-US" sz="3400" dirty="0"/>
           </a:p>
@@ -7716,7 +7716,7 @@
                 <a:ea typeface="Calibri" pitchFamily="34" charset="-122"/>
                 <a:cs typeface="Calibri" pitchFamily="34" charset="-120"/>
               </a:rPr>
-              <a:t>◐</a:t>
+              <a:t>✓</a:t>
             </a:r>
             <a:endParaRPr lang="en-US" sz="1200" dirty="0"/>
           </a:p>
@@ -7848,7 +7848,7 @@
                 <a:ea typeface="Calibri" pitchFamily="34" charset="-122"/>
                 <a:cs typeface="Calibri" pitchFamily="34" charset="-120"/>
               </a:rPr>
-              <a:t>○</a:t>
+              <a:t>✓</a:t>
             </a:r>
             <a:endParaRPr lang="en-US" sz="1200" dirty="0"/>
           </a:p>
@@ -7955,7 +7955,7 @@
                 <a:ea typeface="Calibri" pitchFamily="34" charset="-122"/>
                 <a:cs typeface="Calibri" pitchFamily="34" charset="-120"/>
               </a:rPr>
-              <a:t>Two items are not complete: the cloud database is provisioned locally, not in the cloud, because the application is not yet deployed. We will be explicit about that.</a:t>
+              <a:t>All nine verified on the live system: servicedesk-ai-two.vercel.app on Vercel, API and managed PostgreSQL 16 on Render, WhatsApp through Meta’s Cloud API. Total hosting cost: zero.</a:t>
             </a:r>
             <a:endParaRPr lang="en-US" sz="1200" dirty="0"/>
           </a:p>
@@ -7994,7 +7994,7 @@
                 <a:ea typeface="Calibri" pitchFamily="34" charset="-122"/>
                 <a:cs typeface="Calibri" pitchFamily="34" charset="-120"/>
               </a:rPr>
-              <a:t>ServiceDesk AI  ·  BCSE408L Cloud Computing  ·  Final Demonstration</a:t>
+              <a:t>ServiceDesk AI  ·  BCSE408L Cloud Computing  ·  Review 2 &amp; Final Demonstration</a:t>
             </a:r>
             <a:endParaRPr lang="en-US" sz="900" dirty="0"/>
           </a:p>
@@ -8317,7 +8317,7 @@
                 <a:ea typeface="Calibri" pitchFamily="34" charset="-122"/>
                 <a:cs typeface="Calibri" pitchFamily="34" charset="-120"/>
               </a:rPr>
-              <a:t>Register, raise a complaint, watch it get classified automatically</a:t>
+              <a:t>Send a WhatsApp message from a phone — a ticket is raised, classified and acknowledged in a second</a:t>
             </a:r>
             <a:endParaRPr lang="en-US" sz="1150" dirty="0"/>
           </a:p>
@@ -8839,7 +8839,7 @@
                 <a:ea typeface="Calibri" pitchFamily="34" charset="-122"/>
                 <a:cs typeface="Calibri" pitchFamily="34" charset="-120"/>
               </a:rPr>
-              <a:t>Generate a draft, edit it, send it as a human</a:t>
+              <a:t>Generate a draft, edit it, send it — and watch it arrive on the phone</a:t>
             </a:r>
             <a:endParaRPr lang="en-US" sz="1150" dirty="0"/>
           </a:p>
@@ -9187,7 +9187,7 @@
                 <a:ea typeface="Calibri" pitchFamily="34" charset="-122"/>
                 <a:cs typeface="Calibri" pitchFamily="34" charset="-120"/>
               </a:rPr>
-              <a:t>Dashboards and reports computed from live data</a:t>
+              <a:t>Dashboards, WhatsApp console and audit log computed from the cloud database</a:t>
             </a:r>
             <a:endParaRPr lang="en-US" sz="1150" dirty="0"/>
           </a:p>
@@ -9303,7 +9303,7 @@
                 <a:ea typeface="Calibri" pitchFamily="34" charset="-122"/>
                 <a:cs typeface="Calibri" pitchFamily="34" charset="-120"/>
               </a:rPr>
-              <a:t>No staged screenshots and no rehearsed data — we create a ticket in front of you.</a:t>
+              <a:t>No staged screenshots and no rehearsed data — we create a ticket from a phone in front of you.</a:t>
             </a:r>
             <a:endParaRPr lang="en-US" sz="1200" dirty="0"/>
           </a:p>
@@ -9384,7 +9384,7 @@
                 <a:ea typeface="Calibri" pitchFamily="34" charset="-122"/>
                 <a:cs typeface="Calibri" pitchFamily="34" charset="-120"/>
               </a:rPr>
-              <a:t>ServiceDesk AI  ·  BCSE408L Cloud Computing  ·  Final Demonstration</a:t>
+              <a:t>ServiceDesk AI  ·  BCSE408L Cloud Computing  ·  Review 2 &amp; Final Demonstration</a:t>
             </a:r>
             <a:endParaRPr lang="en-US" sz="900" dirty="0"/>
           </a:p>
@@ -9575,7 +9575,7 @@
                 <a:ea typeface="Calibri" pitchFamily="34" charset="-122"/>
                 <a:cs typeface="Calibri" pitchFamily="34" charset="-120"/>
               </a:rPr>
-              <a:t>Three independently deployable tiers. The browser talks to two hosts and never to the database or the AI provider.</a:t>
+              <a:t>Three independently deployable tiers plus WhatsApp through Meta’s Cloud API. The browser talks to two hosts and never to the database or the AI provider.</a:t>
             </a:r>
             <a:endParaRPr lang="en-US" sz="1250" dirty="0"/>
           </a:p>
@@ -10127,7 +10127,7 @@
                 <a:ea typeface="Calibri" pitchFamily="34" charset="-122"/>
                 <a:cs typeface="Calibri" pitchFamily="34" charset="-120"/>
               </a:rPr>
-              <a:t>AI provider adapter</a:t>
+              <a:t>AI · WhatsApp · embedding adapters</a:t>
             </a:r>
             <a:endParaRPr lang="en-US" sz="1150" dirty="0"/>
           </a:p>
@@ -10381,7 +10381,7 @@
                 <a:ea typeface="Calibri" pitchFamily="34" charset="-122"/>
                 <a:cs typeface="Calibri" pitchFamily="34" charset="-120"/>
               </a:rPr>
-              <a:t>hosted on Supabase</a:t>
+              <a:t>hosted on Render (Singapore)</a:t>
             </a:r>
             <a:endParaRPr lang="en-US" sz="1050" dirty="0"/>
           </a:p>
@@ -10423,7 +10423,7 @@
                 <a:ea typeface="Calibri" pitchFamily="34" charset="-122"/>
                 <a:cs typeface="Calibri" pitchFamily="34" charset="-120"/>
               </a:rPr>
-              <a:t>Managed PostgreSQL 15</a:t>
+              <a:t>Managed PostgreSQL 16 + pgvector</a:t>
             </a:r>
             <a:endParaRPr lang="en-US" sz="1150" dirty="0"/>
           </a:p>
@@ -10443,7 +10443,7 @@
                 <a:ea typeface="Calibri" pitchFamily="34" charset="-122"/>
                 <a:cs typeface="Calibri" pitchFamily="34" charset="-120"/>
               </a:rPr>
-              <a:t>8 tables · enums · constraints</a:t>
+              <a:t>12 tables · enums · constraints</a:t>
             </a:r>
             <a:endParaRPr lang="en-US" sz="1150" dirty="0"/>
           </a:p>
@@ -10463,7 +10463,7 @@
                 <a:ea typeface="Calibri" pitchFamily="34" charset="-122"/>
                 <a:cs typeface="Calibri" pitchFamily="34" charset="-120"/>
               </a:rPr>
-              <a:t>Versioned SQL migrations</a:t>
+              <a:t>5 versioned SQL migrations</a:t>
             </a:r>
             <a:endParaRPr lang="en-US" sz="1150" dirty="0"/>
           </a:p>
@@ -10693,7 +10693,7 @@
                 <a:ea typeface="Calibri" pitchFamily="34" charset="-122"/>
                 <a:cs typeface="Calibri" pitchFamily="34" charset="-120"/>
               </a:rPr>
-              <a:t>Why managed?</a:t>
+              <a:t>Why a Blueprint?</a:t>
             </a:r>
             <a:endParaRPr lang="en-US" sz="1250" dirty="0"/>
           </a:p>
@@ -10735,7 +10735,7 @@
                 <a:ea typeface="Calibri" pitchFamily="34" charset="-122"/>
                 <a:cs typeface="Calibri" pitchFamily="34" charset="-120"/>
               </a:rPr>
-              <a:t>Nobody on this team patches a server. Backups, pooling and TLS come with the service.</a:t>
+              <a:t>render.yaml provisions database and API together. A region mismatch on the first deploy was a one-line fix and a re-apply.</a:t>
             </a:r>
             <a:endParaRPr lang="en-US" sz="1100" dirty="0"/>
           </a:p>
@@ -10889,7 +10889,7 @@
                 <a:ea typeface="Calibri" pitchFamily="34" charset="-122"/>
                 <a:cs typeface="Calibri" pitchFamily="34" charset="-120"/>
               </a:rPr>
-              <a:t>ServiceDesk AI  ·  BCSE408L Cloud Computing  ·  Final Demonstration</a:t>
+              <a:t>ServiceDesk AI  ·  BCSE408L Cloud Computing  ·  Review 2 &amp; Final Demonstration</a:t>
             </a:r>
             <a:endParaRPr lang="en-US" sz="900" dirty="0"/>
           </a:p>
@@ -11080,7 +11080,7 @@
                 <a:ea typeface="Calibri" pitchFamily="34" charset="-122"/>
                 <a:cs typeface="Calibri" pitchFamily="34" charset="-120"/>
               </a:rPr>
-              <a:t>Eight tables, applied by versioned SQL migrations. The ER diagram is derived from the migration file, so it cannot drift from the real schema.</a:t>
+              <a:t>Twelve tables on managed PostgreSQL 16 with pgvector, applied by five versioned SQL migrations on every deploy. The ER diagram is derived from the migrations, so it cannot drift from the real schema.</a:t>
             </a:r>
             <a:endParaRPr lang="en-US" sz="1250" dirty="0"/>
           </a:p>
@@ -11885,7 +11885,7 @@
                 <a:ea typeface="Calibri" pitchFamily="34" charset="-122"/>
                 <a:cs typeface="Calibri" pitchFamily="34" charset="-120"/>
               </a:rPr>
-              <a:t>Per-user, cascade on delete</a:t>
+              <a:t>Per-user, cascade on delete  ·  whatsapp_messages — channel log, UNIQUE provider id makes webhooks idempotent</a:t>
             </a:r>
             <a:endParaRPr lang="en-US" sz="1050" dirty="0"/>
           </a:p>
@@ -12000,7 +12000,7 @@
                 <a:ea typeface="Calibri" pitchFamily="34" charset="-122"/>
                 <a:cs typeface="Calibri" pitchFamily="34" charset="-120"/>
               </a:rPr>
-              <a:t>Actor set to NULL on delete — the record outlives the account</a:t>
+              <a:t>Actor set to NULL on delete  ·  kb_articles / kb_chunks / kb_retrievals — knowledge base with 384-dim vectors</a:t>
             </a:r>
             <a:endParaRPr lang="en-US" sz="1050" dirty="0"/>
           </a:p>
@@ -12384,7 +12384,7 @@
                 <a:ea typeface="Calibri" pitchFamily="34" charset="-122"/>
                 <a:cs typeface="Calibri" pitchFamily="34" charset="-120"/>
               </a:rPr>
-              <a:t>Indexes on every filter column, plus a GIN full-text index backing keyword search across subject and description.</a:t>
+              <a:t>Indexes on every filter column, a GIN full-text index for keyword search, and an HNSW vector index for knowledge-base retrieval.</a:t>
             </a:r>
             <a:endParaRPr lang="en-US" sz="1150" dirty="0"/>
           </a:p>
@@ -12423,7 +12423,7 @@
                 <a:ea typeface="Calibri" pitchFamily="34" charset="-122"/>
                 <a:cs typeface="Calibri" pitchFamily="34" charset="-120"/>
               </a:rPr>
-              <a:t>ServiceDesk AI  ·  BCSE408L Cloud Computing  ·  Final Demonstration</a:t>
+              <a:t>ServiceDesk AI  ·  BCSE408L Cloud Computing  ·  Review 2 &amp; Final Demonstration</a:t>
             </a:r>
             <a:endParaRPr lang="en-US" sz="900" dirty="0"/>
           </a:p>
@@ -13798,7 +13798,7 @@
                 <a:ea typeface="Calibri" pitchFamily="34" charset="-122"/>
                 <a:cs typeface="Calibri" pitchFamily="34" charset="-120"/>
               </a:rPr>
-              <a:t>ServiceDesk AI  ·  BCSE408L Cloud Computing  ·  Final Demonstration</a:t>
+              <a:t>ServiceDesk AI  ·  BCSE408L Cloud Computing  ·  Review 2 &amp; Final Demonstration</a:t>
             </a:r>
             <a:endParaRPr lang="en-US" sz="900" dirty="0"/>
           </a:p>
@@ -15296,7 +15296,7 @@
                 <a:ea typeface="Calibri" pitchFamily="34" charset="-122"/>
                 <a:cs typeface="Calibri" pitchFamily="34" charset="-120"/>
               </a:rPr>
-              <a:t>ServiceDesk AI  ·  BCSE408L Cloud Computing  ·  Final Demonstration</a:t>
+              <a:t>ServiceDesk AI  ·  BCSE408L Cloud Computing  ·  Review 2 &amp; Final Demonstration</a:t>
             </a:r>
             <a:endParaRPr lang="en-US" sz="900" dirty="0"/>
           </a:p>
@@ -15487,7 +15487,7 @@
                 <a:ea typeface="Calibri" pitchFamily="34" charset="-122"/>
                 <a:cs typeface="Calibri" pitchFamily="34" charset="-120"/>
               </a:rPr>
-              <a:t>92 automated tests against a real PostgreSQL database, using the same migration files as production — not mocks. A mock would accept data that a check constraint rejects.</a:t>
+              <a:t>161 automated tests against a real PostgreSQL database, using the same migration files as production — not mocks. They run in CI on every push.</a:t>
             </a:r>
             <a:endParaRPr lang="en-US" sz="1250" dirty="0"/>
           </a:p>
@@ -16103,7 +16103,7 @@
                 <a:ea typeface="Calibri" pitchFamily="34" charset="-122"/>
                 <a:cs typeface="Calibri" pitchFamily="34" charset="-120"/>
               </a:rPr>
-              <a:t>Transition rules, fallback classifier, failure handling</a:t>
+              <a:t>Transition rules, fallback classifier, failure handling  ·  plus 31 knowledge-base and 38 WhatsApp tests</a:t>
             </a:r>
             <a:endParaRPr lang="en-US" sz="1050" dirty="0"/>
           </a:p>
@@ -16171,7 +16171,7 @@
                 <a:ea typeface="Calibri" pitchFamily="34" charset="-122"/>
                 <a:cs typeface="Calibri" pitchFamily="34" charset="-120"/>
               </a:rPr>
-              <a:t>92 passed  ·  0 failed  ·  4 files  ·  ~108 s</a:t>
+              <a:t>161 passed  ·  0 failed  ·  6 files  ·  166 s  ·  19 September 2026</a:t>
             </a:r>
             <a:endParaRPr lang="en-US" sz="1600" dirty="0"/>
           </a:p>
@@ -16286,7 +16286,7 @@
                 <a:ea typeface="Cambria" pitchFamily="34" charset="-122"/>
                 <a:cs typeface="Cambria" pitchFamily="34" charset="-120"/>
               </a:rPr>
-              <a:t>Three defects found and fixed — before submission, not during it</a:t>
+              <a:t>Defects found and fixed — before submission, not during it</a:t>
             </a:r>
             <a:endParaRPr lang="en-US" sz="1500" dirty="0"/>
           </a:p>
@@ -16667,7 +16667,7 @@
                 <a:ea typeface="Calibri" pitchFamily="34" charset="-122"/>
                 <a:cs typeface="Calibri" pitchFamily="34" charset="-120"/>
               </a:rPr>
-              <a:t>Every chart rendered empty</a:t>
+              <a:t>A vector index returned one row where four matched</a:t>
             </a:r>
             <a:endParaRPr lang="en-US" sz="1250" dirty="0"/>
           </a:p>
@@ -16706,7 +16706,7 @@
                 <a:ea typeface="Calibri" pitchFamily="34" charset="-122"/>
                 <a:cs typeface="Calibri" pitchFamily="34" charset="-120"/>
               </a:rPr>
-              <a:t>Found by looking at the running app</a:t>
+              <a:t>Found by an integration test</a:t>
             </a:r>
             <a:endParaRPr lang="en-US" sz="1000" dirty="0"/>
           </a:p>
@@ -16748,7 +16748,7 @@
                 <a:ea typeface="Calibri" pitchFamily="34" charset="-122"/>
                 <a:cs typeface="Calibri" pitchFamily="34" charset="-120"/>
               </a:rPr>
-              <a:t>Build passed, types passed, API correct — yet no bars drew. Animation under StrictMode.</a:t>
+              <a:t>IVFFlat on a near-empty table silently under-returned. Replaced with HNSW; regression test pinned.</a:t>
             </a:r>
             <a:endParaRPr lang="en-US" sz="1050" dirty="0"/>
           </a:p>
@@ -16787,7 +16787,7 @@
                 <a:ea typeface="Calibri" pitchFamily="34" charset="-122"/>
                 <a:cs typeface="Calibri" pitchFamily="34" charset="-120"/>
               </a:rPr>
-              <a:t>The third is the lesson: a green build proves the code compiles, not that the product works.</a:t>
+              <a:t>The lesson: tests against a real database catch what mocks and green builds cannot.</a:t>
             </a:r>
             <a:endParaRPr lang="en-US" sz="1150" dirty="0"/>
           </a:p>
@@ -16826,7 +16826,7 @@
                 <a:ea typeface="Calibri" pitchFamily="34" charset="-122"/>
                 <a:cs typeface="Calibri" pitchFamily="34" charset="-120"/>
               </a:rPr>
-              <a:t>ServiceDesk AI  ·  BCSE408L Cloud Computing  ·  Final Demonstration</a:t>
+              <a:t>ServiceDesk AI  ·  BCSE408L Cloud Computing  ·  Review 2 &amp; Final Demonstration</a:t>
             </a:r>
             <a:endParaRPr lang="en-US" sz="900" dirty="0"/>
           </a:p>
@@ -17273,7 +17273,7 @@
                 <a:ea typeface="Calibri" pitchFamily="34" charset="-122"/>
                 <a:cs typeface="Calibri" pitchFamily="34" charset="-120"/>
               </a:rPr>
-              <a:t>REST API — ~40 endpoints across 9 groups</a:t>
+              <a:t>REST API — ~64 endpoints across 11 groups, Swagger UI at /api/docs</a:t>
             </a:r>
             <a:endParaRPr lang="en-US" sz="1200" dirty="0"/>
           </a:p>
@@ -17294,7 +17294,7 @@
                 <a:ea typeface="Calibri" pitchFamily="34" charset="-122"/>
                 <a:cs typeface="Calibri" pitchFamily="34" charset="-120"/>
               </a:rPr>
-              <a:t>Responsive UI verified at 375, 768 and 1280 px</a:t>
+              <a:t>Responsive UI verified at 390, 768 and 1366 px</a:t>
             </a:r>
             <a:endParaRPr lang="en-US" sz="1200" dirty="0"/>
           </a:p>
@@ -17336,7 +17336,7 @@
                 <a:ea typeface="Calibri" pitchFamily="34" charset="-122"/>
                 <a:cs typeface="Calibri" pitchFamily="34" charset="-120"/>
               </a:rPr>
-              <a:t>Backend typecheck and strict frontend build pass</a:t>
+              <a:t>Live on Vercel + Render with managed PostgreSQL; CI green on every push</a:t>
             </a:r>
             <a:endParaRPr lang="en-US" sz="1200" dirty="0"/>
           </a:p>
@@ -17357,7 +17357,7 @@
                 <a:ea typeface="Calibri" pitchFamily="34" charset="-122"/>
                 <a:cs typeface="Calibri" pitchFamily="34" charset="-120"/>
               </a:rPr>
-              <a:t>Migrations apply cleanly to real PostgreSQL</a:t>
+              <a:t>WhatsApp two-way channel live through Meta’s Cloud API</a:t>
             </a:r>
             <a:endParaRPr lang="en-US" sz="1200" dirty="0"/>
           </a:p>
@@ -17378,7 +17378,7 @@
                 <a:ea typeface="Calibri" pitchFamily="34" charset="-122"/>
                 <a:cs typeface="Calibri" pitchFamily="34" charset="-120"/>
               </a:rPr>
-              <a:t>All three roles exercised end to end in a browser</a:t>
+              <a:t>All three roles exercised end to end on the live system and from a phone</a:t>
             </a:r>
             <a:endParaRPr lang="en-US" sz="1200" dirty="0"/>
           </a:p>
@@ -17592,7 +17592,7 @@
                 <a:ea typeface="Calibri" pitchFamily="34" charset="-122"/>
                 <a:cs typeface="Calibri" pitchFamily="34" charset="-120"/>
               </a:rPr>
-              <a:t>Not deployed — no hosting account provisioned, so there is no public URL</a:t>
+              <a:t>No automated frontend tests — verified manually across roles and viewports</a:t>
             </a:r>
             <a:endParaRPr lang="en-US" sz="1200" dirty="0"/>
           </a:p>
@@ -17613,7 +17613,7 @@
                 <a:ea typeface="Calibri" pitchFamily="34" charset="-122"/>
                 <a:cs typeface="Calibri" pitchFamily="34" charset="-120"/>
               </a:rPr>
-              <a:t>Cloud database instance not provisioned (schema runs on local PostgreSQL)</a:t>
+              <a:t>Refresh tokens not individually revocable — deactivation is the mitigation</a:t>
             </a:r>
             <a:endParaRPr lang="en-US" sz="1200" dirty="0"/>
           </a:p>
@@ -17655,7 +17655,7 @@
                 <a:ea typeface="Calibri" pitchFamily="34" charset="-122"/>
                 <a:cs typeface="Calibri" pitchFamily="34" charset="-120"/>
               </a:rPr>
-              <a:t>No automated frontend tests — manual verification only</a:t>
+              <a:t>Live LLM path not in the automated suite; its failure handling is</a:t>
             </a:r>
             <a:endParaRPr lang="en-US" sz="1200" dirty="0"/>
           </a:p>
@@ -17676,7 +17676,7 @@
                 <a:ea typeface="Calibri" pitchFamily="34" charset="-122"/>
                 <a:cs typeface="Calibri" pitchFamily="34" charset="-120"/>
               </a:rPr>
-              <a:t>No load or performance testing under concurrency</a:t>
+              <a:t>Meta test number limited to five verified phones until business verification</a:t>
             </a:r>
             <a:endParaRPr lang="en-US" sz="1200" dirty="0"/>
           </a:p>
@@ -17747,7 +17747,7 @@
                 <a:ea typeface="Calibri" pitchFamily="34" charset="-122"/>
                 <a:cs typeface="Calibri" pitchFamily="34" charset="-120"/>
               </a:rPr>
-              <a:t>Deployment is the single blocking item. The procedure is fully documented and configured — roughly 75 minutes of work — and the live URL, the cloud database and the screenshots all depend on it.</a:t>
+              <a:t>Every mandatory requirement is complete and verified on the live system. The items on the right are limitations we chose to state rather than hide.</a:t>
             </a:r>
             <a:endParaRPr lang="en-US" sz="1200" dirty="0"/>
           </a:p>
@@ -17786,7 +17786,7 @@
                 <a:ea typeface="Calibri" pitchFamily="34" charset="-122"/>
                 <a:cs typeface="Calibri" pitchFamily="34" charset="-120"/>
               </a:rPr>
-              <a:t>ServiceDesk AI  ·  BCSE408L Cloud Computing  ·  Final Demonstration</a:t>
+              <a:t>ServiceDesk AI  ·  BCSE408L Cloud Computing  ·  Review 2 &amp; Final Demonstration</a:t>
             </a:r>
             <a:endParaRPr lang="en-US" sz="900" dirty="0"/>
           </a:p>

</xml_diff>